<commit_message>
update frontend flow and deployment configuration.
This commit adds new frontend integration/auth pages, refreshes forecast artifacts, and updates Render settings to point the frontend at the active backend service.

Made-with: Cursor
</commit_message>
<xml_diff>
--- a/chatbot/ppt.pptx
+++ b/chatbot/ppt.pptx
@@ -111,6 +111,11 @@
       </a:defRPr>
     </a:lvl9pPr>
   </p:defaultTextStyle>
+  <p:extLst>
+    <p:ext uri="{EFAFB233-063F-42B5-8137-9DF3F51BA10A}">
+      <p15:sldGuideLst xmlns:p15="http://schemas.microsoft.com/office/powerpoint/2012/main"/>
+    </p:ext>
+  </p:extLst>
 </p:presentation>
 </file>
 
@@ -196,7 +201,7 @@
           <a:p>
             <a:fld id="{F5DDFEC2-8BF9-41CE-A848-226930892C50}" type="datetimeFigureOut">
               <a:rPr lang="en-IN" smtClean="0"/>
-              <a:t>08-04-2026</a:t>
+              <a:t>14-04-2026</a:t>
             </a:fld>
             <a:endParaRPr lang="en-IN"/>
           </a:p>
@@ -707,7 +712,7 @@
           <a:p>
             <a:fld id="{D02C5C96-F11C-4421-8C89-5AD1BED137B5}" type="datetimeFigureOut">
               <a:rPr lang="en-IN" smtClean="0"/>
-              <a:t>08-04-2026</a:t>
+              <a:t>14-04-2026</a:t>
             </a:fld>
             <a:endParaRPr lang="en-IN"/>
           </a:p>
@@ -907,7 +912,7 @@
           <a:p>
             <a:fld id="{D02C5C96-F11C-4421-8C89-5AD1BED137B5}" type="datetimeFigureOut">
               <a:rPr lang="en-IN" smtClean="0"/>
-              <a:t>08-04-2026</a:t>
+              <a:t>14-04-2026</a:t>
             </a:fld>
             <a:endParaRPr lang="en-IN"/>
           </a:p>
@@ -1117,7 +1122,7 @@
           <a:p>
             <a:fld id="{D02C5C96-F11C-4421-8C89-5AD1BED137B5}" type="datetimeFigureOut">
               <a:rPr lang="en-IN" smtClean="0"/>
-              <a:t>08-04-2026</a:t>
+              <a:t>14-04-2026</a:t>
             </a:fld>
             <a:endParaRPr lang="en-IN"/>
           </a:p>
@@ -1317,7 +1322,7 @@
           <a:p>
             <a:fld id="{D02C5C96-F11C-4421-8C89-5AD1BED137B5}" type="datetimeFigureOut">
               <a:rPr lang="en-IN" smtClean="0"/>
-              <a:t>08-04-2026</a:t>
+              <a:t>14-04-2026</a:t>
             </a:fld>
             <a:endParaRPr lang="en-IN"/>
           </a:p>
@@ -1593,7 +1598,7 @@
           <a:p>
             <a:fld id="{D02C5C96-F11C-4421-8C89-5AD1BED137B5}" type="datetimeFigureOut">
               <a:rPr lang="en-IN" smtClean="0"/>
-              <a:t>08-04-2026</a:t>
+              <a:t>14-04-2026</a:t>
             </a:fld>
             <a:endParaRPr lang="en-IN"/>
           </a:p>
@@ -1861,7 +1866,7 @@
           <a:p>
             <a:fld id="{D02C5C96-F11C-4421-8C89-5AD1BED137B5}" type="datetimeFigureOut">
               <a:rPr lang="en-IN" smtClean="0"/>
-              <a:t>08-04-2026</a:t>
+              <a:t>14-04-2026</a:t>
             </a:fld>
             <a:endParaRPr lang="en-IN"/>
           </a:p>
@@ -2276,7 +2281,7 @@
           <a:p>
             <a:fld id="{D02C5C96-F11C-4421-8C89-5AD1BED137B5}" type="datetimeFigureOut">
               <a:rPr lang="en-IN" smtClean="0"/>
-              <a:t>08-04-2026</a:t>
+              <a:t>14-04-2026</a:t>
             </a:fld>
             <a:endParaRPr lang="en-IN"/>
           </a:p>
@@ -2418,7 +2423,7 @@
           <a:p>
             <a:fld id="{D02C5C96-F11C-4421-8C89-5AD1BED137B5}" type="datetimeFigureOut">
               <a:rPr lang="en-IN" smtClean="0"/>
-              <a:t>08-04-2026</a:t>
+              <a:t>14-04-2026</a:t>
             </a:fld>
             <a:endParaRPr lang="en-IN"/>
           </a:p>
@@ -2531,7 +2536,7 @@
           <a:p>
             <a:fld id="{D02C5C96-F11C-4421-8C89-5AD1BED137B5}" type="datetimeFigureOut">
               <a:rPr lang="en-IN" smtClean="0"/>
-              <a:t>08-04-2026</a:t>
+              <a:t>14-04-2026</a:t>
             </a:fld>
             <a:endParaRPr lang="en-IN"/>
           </a:p>
@@ -2844,7 +2849,7 @@
           <a:p>
             <a:fld id="{D02C5C96-F11C-4421-8C89-5AD1BED137B5}" type="datetimeFigureOut">
               <a:rPr lang="en-IN" smtClean="0"/>
-              <a:t>08-04-2026</a:t>
+              <a:t>14-04-2026</a:t>
             </a:fld>
             <a:endParaRPr lang="en-IN"/>
           </a:p>
@@ -3133,7 +3138,7 @@
           <a:p>
             <a:fld id="{D02C5C96-F11C-4421-8C89-5AD1BED137B5}" type="datetimeFigureOut">
               <a:rPr lang="en-IN" smtClean="0"/>
-              <a:t>08-04-2026</a:t>
+              <a:t>14-04-2026</a:t>
             </a:fld>
             <a:endParaRPr lang="en-IN"/>
           </a:p>
@@ -3376,7 +3381,7 @@
           <a:p>
             <a:fld id="{D02C5C96-F11C-4421-8C89-5AD1BED137B5}" type="datetimeFigureOut">
               <a:rPr lang="en-IN" smtClean="0"/>
-              <a:t>08-04-2026</a:t>
+              <a:t>14-04-2026</a:t>
             </a:fld>
             <a:endParaRPr lang="en-IN"/>
           </a:p>

</xml_diff>